<commit_message>
Edit Form UI complete, implementation in progress
</commit_message>
<xml_diff>
--- a/JAT/JAT Logo designs.pptx
+++ b/JAT/JAT Logo designs.pptx
@@ -105,7 +105,49 @@
       </a:defRPr>
     </a:lvl9pPr>
   </p:defaultTextStyle>
+  <p:extLst>
+    <p:ext uri="{EFAFB233-063F-42B5-8137-9DF3F51BA10A}">
+      <p15:sldGuideLst xmlns:p15="http://schemas.microsoft.com/office/powerpoint/2012/main"/>
+    </p:ext>
+  </p:extLst>
 </p:presentation>
+</file>
+
+<file path=ppt/revisionInfo.xml><?xml version="1.0" encoding="utf-8"?>
+<p1510:revInfo xmlns:a="http://schemas.openxmlformats.org/drawingml/2006/main" xmlns:r="http://schemas.openxmlformats.org/officeDocument/2006/relationships" xmlns:p1510="http://schemas.microsoft.com/office/powerpoint/2015/10/main">
+  <p1510:revLst>
+    <p1510:client id="{A1581387-9EED-45FC-8821-BCC0E09164DA}" v="4" dt="2026-05-22T16:46:05.592"/>
+  </p1510:revLst>
+</p1510:revInfo>
+</file>
+
+<file path=ppt/changesInfos/changesInfo1.xml><?xml version="1.0" encoding="utf-8"?>
+<pc:chgInfo xmlns:a="http://schemas.openxmlformats.org/drawingml/2006/main" xmlns:r="http://schemas.openxmlformats.org/officeDocument/2006/relationships" xmlns:ac="http://schemas.microsoft.com/office/drawing/2013/main/command" xmlns:pc="http://schemas.microsoft.com/office/powerpoint/2013/main/command">
+  <pc:docChgLst>
+    <pc:chgData name="Leroy Sturdivent" userId="41e582f7acb13e6a" providerId="LiveId" clId="{DC1EEE44-BCCF-44CE-8B02-313174E91A04}"/>
+    <pc:docChg chg="modSld">
+      <pc:chgData name="Leroy Sturdivent" userId="41e582f7acb13e6a" providerId="LiveId" clId="{DC1EEE44-BCCF-44CE-8B02-313174E91A04}" dt="2026-05-22T16:46:00.430" v="5"/>
+      <pc:docMkLst>
+        <pc:docMk/>
+      </pc:docMkLst>
+      <pc:sldChg chg="modSp mod">
+        <pc:chgData name="Leroy Sturdivent" userId="41e582f7acb13e6a" providerId="LiveId" clId="{DC1EEE44-BCCF-44CE-8B02-313174E91A04}" dt="2026-05-22T16:46:00.430" v="5"/>
+        <pc:sldMkLst>
+          <pc:docMk/>
+          <pc:sldMk cId="1729949029" sldId="256"/>
+        </pc:sldMkLst>
+        <pc:spChg chg="mod">
+          <ac:chgData name="Leroy Sturdivent" userId="41e582f7acb13e6a" providerId="LiveId" clId="{DC1EEE44-BCCF-44CE-8B02-313174E91A04}" dt="2026-05-22T16:46:00.430" v="5"/>
+          <ac:spMkLst>
+            <pc:docMk/>
+            <pc:sldMk cId="1729949029" sldId="256"/>
+            <ac:spMk id="8" creationId="{06A4724B-43BA-CF9A-29CD-C23A8341E2F8}"/>
+          </ac:spMkLst>
+        </pc:spChg>
+      </pc:sldChg>
+    </pc:docChg>
+  </pc:docChgLst>
+</pc:chgInfo>
 </file>
 
 <file path=ppt/slideLayouts/slideLayout1.xml><?xml version="1.0" encoding="utf-8"?>
@@ -255,7 +297,7 @@
           <a:p>
             <a:fld id="{40DD23B6-2C4D-45C6-B558-EA1C13F262B2}" type="datetimeFigureOut">
               <a:rPr lang="en-US" smtClean="0"/>
-              <a:t>5/20/2026</a:t>
+              <a:t>5/22/2026</a:t>
             </a:fld>
             <a:endParaRPr lang="en-US"/>
           </a:p>
@@ -453,7 +495,7 @@
           <a:p>
             <a:fld id="{40DD23B6-2C4D-45C6-B558-EA1C13F262B2}" type="datetimeFigureOut">
               <a:rPr lang="en-US" smtClean="0"/>
-              <a:t>5/20/2026</a:t>
+              <a:t>5/22/2026</a:t>
             </a:fld>
             <a:endParaRPr lang="en-US"/>
           </a:p>
@@ -661,7 +703,7 @@
           <a:p>
             <a:fld id="{40DD23B6-2C4D-45C6-B558-EA1C13F262B2}" type="datetimeFigureOut">
               <a:rPr lang="en-US" smtClean="0"/>
-              <a:t>5/20/2026</a:t>
+              <a:t>5/22/2026</a:t>
             </a:fld>
             <a:endParaRPr lang="en-US"/>
           </a:p>
@@ -859,7 +901,7 @@
           <a:p>
             <a:fld id="{40DD23B6-2C4D-45C6-B558-EA1C13F262B2}" type="datetimeFigureOut">
               <a:rPr lang="en-US" smtClean="0"/>
-              <a:t>5/20/2026</a:t>
+              <a:t>5/22/2026</a:t>
             </a:fld>
             <a:endParaRPr lang="en-US"/>
           </a:p>
@@ -1134,7 +1176,7 @@
           <a:p>
             <a:fld id="{40DD23B6-2C4D-45C6-B558-EA1C13F262B2}" type="datetimeFigureOut">
               <a:rPr lang="en-US" smtClean="0"/>
-              <a:t>5/20/2026</a:t>
+              <a:t>5/22/2026</a:t>
             </a:fld>
             <a:endParaRPr lang="en-US"/>
           </a:p>
@@ -1399,7 +1441,7 @@
           <a:p>
             <a:fld id="{40DD23B6-2C4D-45C6-B558-EA1C13F262B2}" type="datetimeFigureOut">
               <a:rPr lang="en-US" smtClean="0"/>
-              <a:t>5/20/2026</a:t>
+              <a:t>5/22/2026</a:t>
             </a:fld>
             <a:endParaRPr lang="en-US"/>
           </a:p>
@@ -1811,7 +1853,7 @@
           <a:p>
             <a:fld id="{40DD23B6-2C4D-45C6-B558-EA1C13F262B2}" type="datetimeFigureOut">
               <a:rPr lang="en-US" smtClean="0"/>
-              <a:t>5/20/2026</a:t>
+              <a:t>5/22/2026</a:t>
             </a:fld>
             <a:endParaRPr lang="en-US"/>
           </a:p>
@@ -1952,7 +1994,7 @@
           <a:p>
             <a:fld id="{40DD23B6-2C4D-45C6-B558-EA1C13F262B2}" type="datetimeFigureOut">
               <a:rPr lang="en-US" smtClean="0"/>
-              <a:t>5/20/2026</a:t>
+              <a:t>5/22/2026</a:t>
             </a:fld>
             <a:endParaRPr lang="en-US"/>
           </a:p>
@@ -2065,7 +2107,7 @@
           <a:p>
             <a:fld id="{40DD23B6-2C4D-45C6-B558-EA1C13F262B2}" type="datetimeFigureOut">
               <a:rPr lang="en-US" smtClean="0"/>
-              <a:t>5/20/2026</a:t>
+              <a:t>5/22/2026</a:t>
             </a:fld>
             <a:endParaRPr lang="en-US"/>
           </a:p>
@@ -2376,7 +2418,7 @@
           <a:p>
             <a:fld id="{40DD23B6-2C4D-45C6-B558-EA1C13F262B2}" type="datetimeFigureOut">
               <a:rPr lang="en-US" smtClean="0"/>
-              <a:t>5/20/2026</a:t>
+              <a:t>5/22/2026</a:t>
             </a:fld>
             <a:endParaRPr lang="en-US"/>
           </a:p>
@@ -2664,7 +2706,7 @@
           <a:p>
             <a:fld id="{40DD23B6-2C4D-45C6-B558-EA1C13F262B2}" type="datetimeFigureOut">
               <a:rPr lang="en-US" smtClean="0"/>
-              <a:t>5/20/2026</a:t>
+              <a:t>5/22/2026</a:t>
             </a:fld>
             <a:endParaRPr lang="en-US"/>
           </a:p>
@@ -2905,7 +2947,7 @@
           <a:p>
             <a:fld id="{40DD23B6-2C4D-45C6-B558-EA1C13F262B2}" type="datetimeFigureOut">
               <a:rPr lang="en-US" smtClean="0"/>
-              <a:t>5/20/2026</a:t>
+              <a:t>5/22/2026</a:t>
             </a:fld>
             <a:endParaRPr lang="en-US"/>
           </a:p>
@@ -3470,7 +3512,7 @@
               </a:rPr>
               <a:t>pplication</a:t>
             </a:r>
-            <a:endParaRPr lang="en-US" dirty="0"/>
+            <a:endParaRPr lang="en-US" b="1" dirty="0"/>
           </a:p>
         </p:txBody>
       </p:sp>

</xml_diff>

<commit_message>
Updated UI and Entry class
</commit_message>
<xml_diff>
--- a/JAT/JAT Logo designs.pptx
+++ b/JAT/JAT Logo designs.pptx
@@ -126,22 +126,38 @@
   <pc:docChgLst>
     <pc:chgData name="Leroy Sturdivent" userId="41e582f7acb13e6a" providerId="LiveId" clId="{DC1EEE44-BCCF-44CE-8B02-313174E91A04}"/>
     <pc:docChg chg="modSld">
-      <pc:chgData name="Leroy Sturdivent" userId="41e582f7acb13e6a" providerId="LiveId" clId="{DC1EEE44-BCCF-44CE-8B02-313174E91A04}" dt="2026-05-22T16:46:00.430" v="5"/>
+      <pc:chgData name="Leroy Sturdivent" userId="41e582f7acb13e6a" providerId="LiveId" clId="{DC1EEE44-BCCF-44CE-8B02-313174E91A04}" dt="2026-05-22T17:52:22.612" v="7" actId="1076"/>
       <pc:docMkLst>
         <pc:docMk/>
       </pc:docMkLst>
       <pc:sldChg chg="modSp mod">
-        <pc:chgData name="Leroy Sturdivent" userId="41e582f7acb13e6a" providerId="LiveId" clId="{DC1EEE44-BCCF-44CE-8B02-313174E91A04}" dt="2026-05-22T16:46:00.430" v="5"/>
+        <pc:chgData name="Leroy Sturdivent" userId="41e582f7acb13e6a" providerId="LiveId" clId="{DC1EEE44-BCCF-44CE-8B02-313174E91A04}" dt="2026-05-22T17:52:22.612" v="7" actId="1076"/>
         <pc:sldMkLst>
           <pc:docMk/>
           <pc:sldMk cId="1729949029" sldId="256"/>
         </pc:sldMkLst>
+        <pc:spChg chg="mod">
+          <ac:chgData name="Leroy Sturdivent" userId="41e582f7acb13e6a" providerId="LiveId" clId="{DC1EEE44-BCCF-44CE-8B02-313174E91A04}" dt="2026-05-22T17:52:18.084" v="6" actId="1076"/>
+          <ac:spMkLst>
+            <pc:docMk/>
+            <pc:sldMk cId="1729949029" sldId="256"/>
+            <ac:spMk id="4" creationId="{818D01FF-BEB5-C7EE-5EBB-02C2BB8E3797}"/>
+          </ac:spMkLst>
+        </pc:spChg>
         <pc:spChg chg="mod">
           <ac:chgData name="Leroy Sturdivent" userId="41e582f7acb13e6a" providerId="LiveId" clId="{DC1EEE44-BCCF-44CE-8B02-313174E91A04}" dt="2026-05-22T16:46:00.430" v="5"/>
           <ac:spMkLst>
             <pc:docMk/>
             <pc:sldMk cId="1729949029" sldId="256"/>
             <ac:spMk id="8" creationId="{06A4724B-43BA-CF9A-29CD-C23A8341E2F8}"/>
+          </ac:spMkLst>
+        </pc:spChg>
+        <pc:spChg chg="mod">
+          <ac:chgData name="Leroy Sturdivent" userId="41e582f7acb13e6a" providerId="LiveId" clId="{DC1EEE44-BCCF-44CE-8B02-313174E91A04}" dt="2026-05-22T17:52:22.612" v="7" actId="1076"/>
+          <ac:spMkLst>
+            <pc:docMk/>
+            <pc:sldMk cId="1729949029" sldId="256"/>
+            <ac:spMk id="10" creationId="{AC2607EE-B2D1-C739-1319-7DBB04CE951C}"/>
           </ac:spMkLst>
         </pc:spChg>
       </pc:sldChg>
@@ -3378,7 +3394,7 @@
         </p:nvSpPr>
         <p:spPr>
           <a:xfrm>
-            <a:off x="-774969" y="1369365"/>
+            <a:off x="-1630102" y="2554698"/>
             <a:ext cx="8929991" cy="1015663"/>
           </a:xfrm>
           <a:prstGeom prst="rect">
@@ -3530,7 +3546,7 @@
         </p:nvSpPr>
         <p:spPr>
           <a:xfrm>
-            <a:off x="5737699" y="3934838"/>
+            <a:off x="8559276" y="2432791"/>
             <a:ext cx="6094378" cy="1015663"/>
           </a:xfrm>
           <a:prstGeom prst="rect">

</xml_diff>